<commit_message>
Sync decision framework to the When/Think/Difficulty cards; fix stale lab and README wording
- decision-framework.md: columns now match the leadership cards, sort-by-difficulty guidance
- README: CHALLENGE 1/2 tags become CHALLENGE, matching the lab slides
- M0/M1/M4 overviews and SETUP: point at spec, lab, and walkthrough docs instead of a per-feature README
- M5 outline and deck notes: name the new columns

Co-Authored-By: Claude Fable 5.1 <noreply@anthropic.com>
</commit_message>
<xml_diff>
--- a/docs/slides/pptx/M5-closing.pptx
+++ b/docs/slides/pptx/M5-closing.pptx
@@ -742,7 +742,7 @@
           </a:p>
           <a:p>
             <a:r>
-              <a:t>The full table lives in decision-framework.md: # · Feature · When to reach for this · Cost &amp; effort · The one-liner. (Paste the real table over this slide, or demo it from the repo.)</a:t>
+              <a:t>The full table lives in decision-framework.md: # · Feature · When · Think · Difficulty, the same three fields as every card today. (Paste the real table over this slide, or demo it from the repo.)</a:t>
             </a:r>
           </a:p>
           <a:p>
@@ -822,7 +822,7 @@
           </a:p>
           <a:p>
             <a:r>
-              <a:t>The full table lives in decision-framework.md: # · Feature · When to reach for this · Cost &amp; effort · The one-liner. (Paste the real table over this slide, or demo it from the repo.)</a:t>
+              <a:t>The full table lives in decision-framework.md: # · Feature · When · Think · Difficulty, the same three fields as every card today. (Paste the real table over this slide, or demo it from the repo.)</a:t>
             </a:r>
           </a:p>
           <a:p>
@@ -902,7 +902,7 @@
           </a:p>
           <a:p>
             <a:r>
-              <a:t>The full table lives in decision-framework.md: # · Feature · When to reach for this · Cost &amp; effort · The one-liner. (Paste the real table over this slide, or demo it from the repo.)</a:t>
+              <a:t>The full table lives in decision-framework.md: # · Feature · When · Think · Difficulty, the same three fields as every card today. (Paste the real table over this slide, or demo it from the repo.)</a:t>
             </a:r>
           </a:p>
           <a:p>
@@ -982,7 +982,7 @@
           </a:p>
           <a:p>
             <a:r>
-              <a:t>The full table lives in decision-framework.md: # · Feature · When to reach for this · Cost &amp; effort · The one-liner. (Paste the real table over this slide, or demo it from the repo.)</a:t>
+              <a:t>The full table lives in decision-framework.md: # · Feature · When · Think · Difficulty, the same three fields as every card today. (Paste the real table over this slide, or demo it from the repo.)</a:t>
             </a:r>
           </a:p>
           <a:p>
@@ -2612,7 +2612,7 @@
           </a:p>
           <a:p>
             <a:r>
-              <a:t>The full table lives in decision-framework.md: # · Feature · When to reach for this · Cost &amp; effort · The one-liner. (Paste the real table over this slide, or demo it from the repo.)</a:t>
+              <a:t>The full table lives in decision-framework.md: # · Feature · When · Think · Difficulty, the same three fields as every card today. (Paste the real table over this slide, or demo it from the repo.)</a:t>
             </a:r>
           </a:p>
           <a:p>
@@ -2692,7 +2692,7 @@
           </a:p>
           <a:p>
             <a:r>
-              <a:t>The full table lives in decision-framework.md: # · Feature · When to reach for this · Cost &amp; effort · The one-liner. (Paste the real table over this slide, or demo it from the repo.)</a:t>
+              <a:t>The full table lives in decision-framework.md: # · Feature · When · Think · Difficulty, the same three fields as every card today. (Paste the real table over this slide, or demo it from the repo.)</a:t>
             </a:r>
           </a:p>
           <a:p>
@@ -2772,7 +2772,7 @@
           </a:p>
           <a:p>
             <a:r>
-              <a:t>The full table lives in decision-framework.md: # · Feature · When to reach for this · Cost &amp; effort · The one-liner. (Paste the real table over this slide, or demo it from the repo.)</a:t>
+              <a:t>The full table lives in decision-framework.md: # · Feature · When · Think · Difficulty, the same three fields as every card today. (Paste the real table over this slide, or demo it from the repo.)</a:t>
             </a:r>
           </a:p>
           <a:p>
@@ -2852,7 +2852,7 @@
           </a:p>
           <a:p>
             <a:r>
-              <a:t>The full table lives in decision-framework.md: # · Feature · When to reach for this · Cost &amp; effort · The one-liner. (Paste the real table over this slide, or demo it from the repo.)</a:t>
+              <a:t>The full table lives in decision-framework.md: # · Feature · When · Think · Difficulty, the same three fields as every card today. (Paste the real table over this slide, or demo it from the repo.)</a:t>
             </a:r>
           </a:p>
           <a:p>
@@ -2932,7 +2932,7 @@
           </a:p>
           <a:p>
             <a:r>
-              <a:t>The full table lives in decision-framework.md: # · Feature · When to reach for this · Cost &amp; effort · The one-liner. (Paste the real table over this slide, or demo it from the repo.)</a:t>
+              <a:t>The full table lives in decision-framework.md: # · Feature · When · Think · Difficulty, the same three fields as every card today. (Paste the real table over this slide, or demo it from the repo.)</a:t>
             </a:r>
           </a:p>
           <a:p>
@@ -3012,7 +3012,7 @@
           </a:p>
           <a:p>
             <a:r>
-              <a:t>The full table lives in decision-framework.md: # · Feature · When to reach for this · Cost &amp; effort · The one-liner. (Paste the real table over this slide, or demo it from the repo.)</a:t>
+              <a:t>The full table lives in decision-framework.md: # · Feature · When · Think · Difficulty, the same three fields as every card today. (Paste the real table over this slide, or demo it from the repo.)</a:t>
             </a:r>
           </a:p>
           <a:p>

</xml_diff>